<commit_message>
Update gitbook 2026-08-27 16:44:27
</commit_message>
<xml_diff>
--- a/Week02/BasicHtmlElements.pptx
+++ b/Week02/BasicHtmlElements.pptx
@@ -5023,7 +5023,7 @@
           <a:p>
             <a:fld id="{5958763E-B898-436D-883D-03711491D54A}" type="datetimeFigureOut">
               <a:rPr lang="en-US" smtClean="0"/>
-              <a:t>1/30/2026</a:t>
+              <a:t>8/27/2026</a:t>
             </a:fld>
             <a:endParaRPr lang="en-US"/>
           </a:p>
@@ -8987,6 +8987,7 @@
             <a:off x="0" y="1152475"/>
             <a:ext cx="9144000" cy="3416400"/>
           </a:xfrm>
+          <a:noFill/>
         </p:spPr>
         <p:txBody>
           <a:bodyPr anchor="ctr">
@@ -9000,23 +9001,23 @@
             <a:r>
               <a:rPr lang="en-US" sz="2000" b="1" dirty="0">
                 <a:solidFill>
-                  <a:schemeClr val="tx1"/>
-                </a:solidFill>
-                <a:highlight>
-                  <a:srgbClr val="C0C0C0"/>
-                </a:highlight>
-                <a:hlinkClick r:id="rId3"/>
+                  <a:schemeClr val="bg1"/>
+                </a:solidFill>
+                <a:hlinkClick r:id="rId3">
+                  <a:extLst>
+                    <a:ext uri="{A12FA001-AC4F-418D-AE19-62706E023703}">
+                      <ahyp:hlinkClr xmlns:ahyp="http://schemas.microsoft.com/office/drawing/2018/hyperlinkcolor" val="tx"/>
+                    </a:ext>
+                  </a:extLst>
+                </a:hlinkClick>
               </a:rPr>
-              <a:t>https://jsfiddle.net/mxtdvL10/</a:t>
+              <a:t>https://hytop.onrender.com/e/html-elements-example</a:t>
             </a:r>
             <a:r>
               <a:rPr lang="en-US" sz="2000" b="1" dirty="0">
                 <a:solidFill>
-                  <a:schemeClr val="tx1"/>
-                </a:solidFill>
-                <a:highlight>
-                  <a:srgbClr val="C0C0C0"/>
-                </a:highlight>
+                  <a:schemeClr val="bg1"/>
+                </a:solidFill>
               </a:rPr>
               <a:t> </a:t>
             </a:r>
@@ -11217,7 +11218,7 @@
                   </a:extLst>
                 </a:hlinkClick>
               </a:rPr>
-              <a:t>https://jsfiddle.net/Lhodz460/</a:t>
+              <a:t>https://hytop.onrender.com/e/html-attributes-example</a:t>
             </a:r>
             <a:endParaRPr lang="en-US" sz="2400" b="1" dirty="0">
               <a:solidFill>

</xml_diff>